<commit_message>
Rendering Question Page (Without Answers
</commit_message>
<xml_diff>
--- a/ComponentStructure.pptx
+++ b/ComponentStructure.pptx
@@ -104,6 +104,11 @@
       </a:defRPr>
     </a:lvl9pPr>
   </p:defaultTextStyle>
+  <p:extLst>
+    <p:ext uri="{EFAFB233-063F-42B5-8137-9DF3F51BA10A}">
+      <p15:sldGuideLst xmlns:p15="http://schemas.microsoft.com/office/powerpoint/2012/main"/>
+    </p:ext>
+  </p:extLst>
 </p:presentation>
 </file>
 
@@ -256,7 +261,7 @@
           <a:p>
             <a:fld id="{A44E7D89-D63E-440B-95A2-3F577F48FD3E}" type="datetimeFigureOut">
               <a:rPr lang="en-GB" smtClean="0"/>
-              <a:t>30/01/2021</a:t>
+              <a:t>31/01/2021</a:t>
             </a:fld>
             <a:endParaRPr lang="en-GB"/>
           </a:p>
@@ -456,7 +461,7 @@
           <a:p>
             <a:fld id="{A44E7D89-D63E-440B-95A2-3F577F48FD3E}" type="datetimeFigureOut">
               <a:rPr lang="en-GB" smtClean="0"/>
-              <a:t>30/01/2021</a:t>
+              <a:t>31/01/2021</a:t>
             </a:fld>
             <a:endParaRPr lang="en-GB"/>
           </a:p>
@@ -666,7 +671,7 @@
           <a:p>
             <a:fld id="{A44E7D89-D63E-440B-95A2-3F577F48FD3E}" type="datetimeFigureOut">
               <a:rPr lang="en-GB" smtClean="0"/>
-              <a:t>30/01/2021</a:t>
+              <a:t>31/01/2021</a:t>
             </a:fld>
             <a:endParaRPr lang="en-GB"/>
           </a:p>
@@ -866,7 +871,7 @@
           <a:p>
             <a:fld id="{A44E7D89-D63E-440B-95A2-3F577F48FD3E}" type="datetimeFigureOut">
               <a:rPr lang="en-GB" smtClean="0"/>
-              <a:t>30/01/2021</a:t>
+              <a:t>31/01/2021</a:t>
             </a:fld>
             <a:endParaRPr lang="en-GB"/>
           </a:p>
@@ -1142,7 +1147,7 @@
           <a:p>
             <a:fld id="{A44E7D89-D63E-440B-95A2-3F577F48FD3E}" type="datetimeFigureOut">
               <a:rPr lang="en-GB" smtClean="0"/>
-              <a:t>30/01/2021</a:t>
+              <a:t>31/01/2021</a:t>
             </a:fld>
             <a:endParaRPr lang="en-GB"/>
           </a:p>
@@ -1410,7 +1415,7 @@
           <a:p>
             <a:fld id="{A44E7D89-D63E-440B-95A2-3F577F48FD3E}" type="datetimeFigureOut">
               <a:rPr lang="en-GB" smtClean="0"/>
-              <a:t>30/01/2021</a:t>
+              <a:t>31/01/2021</a:t>
             </a:fld>
             <a:endParaRPr lang="en-GB"/>
           </a:p>
@@ -1825,7 +1830,7 @@
           <a:p>
             <a:fld id="{A44E7D89-D63E-440B-95A2-3F577F48FD3E}" type="datetimeFigureOut">
               <a:rPr lang="en-GB" smtClean="0"/>
-              <a:t>30/01/2021</a:t>
+              <a:t>31/01/2021</a:t>
             </a:fld>
             <a:endParaRPr lang="en-GB"/>
           </a:p>
@@ -1967,7 +1972,7 @@
           <a:p>
             <a:fld id="{A44E7D89-D63E-440B-95A2-3F577F48FD3E}" type="datetimeFigureOut">
               <a:rPr lang="en-GB" smtClean="0"/>
-              <a:t>30/01/2021</a:t>
+              <a:t>31/01/2021</a:t>
             </a:fld>
             <a:endParaRPr lang="en-GB"/>
           </a:p>
@@ -2080,7 +2085,7 @@
           <a:p>
             <a:fld id="{A44E7D89-D63E-440B-95A2-3F577F48FD3E}" type="datetimeFigureOut">
               <a:rPr lang="en-GB" smtClean="0"/>
-              <a:t>30/01/2021</a:t>
+              <a:t>31/01/2021</a:t>
             </a:fld>
             <a:endParaRPr lang="en-GB"/>
           </a:p>
@@ -2393,7 +2398,7 @@
           <a:p>
             <a:fld id="{A44E7D89-D63E-440B-95A2-3F577F48FD3E}" type="datetimeFigureOut">
               <a:rPr lang="en-GB" smtClean="0"/>
-              <a:t>30/01/2021</a:t>
+              <a:t>31/01/2021</a:t>
             </a:fld>
             <a:endParaRPr lang="en-GB"/>
           </a:p>
@@ -2682,7 +2687,7 @@
           <a:p>
             <a:fld id="{A44E7D89-D63E-440B-95A2-3F577F48FD3E}" type="datetimeFigureOut">
               <a:rPr lang="en-GB" smtClean="0"/>
-              <a:t>30/01/2021</a:t>
+              <a:t>31/01/2021</a:t>
             </a:fld>
             <a:endParaRPr lang="en-GB"/>
           </a:p>
@@ -2925,7 +2930,7 @@
           <a:p>
             <a:fld id="{A44E7D89-D63E-440B-95A2-3F577F48FD3E}" type="datetimeFigureOut">
               <a:rPr lang="en-GB" smtClean="0"/>
-              <a:t>30/01/2021</a:t>
+              <a:t>31/01/2021</a:t>
             </a:fld>
             <a:endParaRPr lang="en-GB"/>
           </a:p>
@@ -3357,7 +3362,7 @@
         <p:spPr>
           <a:xfrm>
             <a:off x="411062" y="335560"/>
-            <a:ext cx="11325136" cy="6074571"/>
+            <a:ext cx="11325136" cy="6258187"/>
           </a:xfrm>
           <a:prstGeom prst="rect">
             <a:avLst/>
@@ -3534,10 +3539,10 @@
       </p:sp>
       <p:sp>
         <p:nvSpPr>
-          <p:cNvPr id="13" name="Rectangle 12">
-            <a:extLst>
-              <a:ext uri="{FF2B5EF4-FFF2-40B4-BE49-F238E27FC236}">
-                <a16:creationId xmlns:a16="http://schemas.microsoft.com/office/drawing/2014/main" id="{C5739DAE-FE61-4C98-8DBC-37F6424F9B50}"/>
+          <p:cNvPr id="16" name="Rectangle 15">
+            <a:extLst>
+              <a:ext uri="{FF2B5EF4-FFF2-40B4-BE49-F238E27FC236}">
+                <a16:creationId xmlns:a16="http://schemas.microsoft.com/office/drawing/2014/main" id="{CB6B30B4-5F78-4EF5-86A5-C87AB7C0EECD}"/>
               </a:ext>
             </a:extLst>
           </p:cNvPr>
@@ -3546,8 +3551,8 @@
         </p:nvSpPr>
         <p:spPr>
           <a:xfrm>
-            <a:off x="1085461" y="2016742"/>
-            <a:ext cx="5421086" cy="3870874"/>
+            <a:off x="534955" y="1758274"/>
+            <a:ext cx="11100318" cy="4651856"/>
           </a:xfrm>
           <a:prstGeom prst="rect">
             <a:avLst/>
@@ -3574,7 +3579,7 @@
             <a:pPr algn="ctr"/>
             <a:r>
               <a:rPr lang="en-GB" dirty="0" err="1"/>
-              <a:t>HomePage.tsx</a:t>
+              <a:t>Page.tsx</a:t>
             </a:r>
             <a:endParaRPr lang="en-GB" dirty="0"/>
           </a:p>
@@ -3582,10 +3587,10 @@
       </p:sp>
       <p:sp>
         <p:nvSpPr>
-          <p:cNvPr id="5" name="Rectangle 4">
-            <a:extLst>
-              <a:ext uri="{FF2B5EF4-FFF2-40B4-BE49-F238E27FC236}">
-                <a16:creationId xmlns:a16="http://schemas.microsoft.com/office/drawing/2014/main" id="{6939E023-390B-4E1C-94A8-5C94AE9DDE47}"/>
+          <p:cNvPr id="17" name="Rectangle 16">
+            <a:extLst>
+              <a:ext uri="{FF2B5EF4-FFF2-40B4-BE49-F238E27FC236}">
+                <a16:creationId xmlns:a16="http://schemas.microsoft.com/office/drawing/2014/main" id="{3EE5B209-AC34-4ED6-AB66-C493580892F1}"/>
               </a:ext>
             </a:extLst>
           </p:cNvPr>
@@ -3594,8 +3599,8 @@
         </p:nvSpPr>
         <p:spPr>
           <a:xfrm>
-            <a:off x="1254968" y="3598512"/>
-            <a:ext cx="5066522" cy="2175637"/>
+            <a:off x="3546410" y="2348916"/>
+            <a:ext cx="5099179" cy="423147"/>
           </a:xfrm>
           <a:prstGeom prst="rect">
             <a:avLst/>
@@ -3622,7 +3627,7 @@
             <a:pPr algn="ctr"/>
             <a:r>
               <a:rPr lang="en-GB" dirty="0" err="1"/>
-              <a:t>QuestionList.tsx</a:t>
+              <a:t>PageTitle.tsx</a:t>
             </a:r>
             <a:endParaRPr lang="en-GB" dirty="0"/>
           </a:p>
@@ -3630,10 +3635,10 @@
       </p:sp>
       <p:sp>
         <p:nvSpPr>
-          <p:cNvPr id="6" name="Rectangle 5">
-            <a:extLst>
-              <a:ext uri="{FF2B5EF4-FFF2-40B4-BE49-F238E27FC236}">
-                <a16:creationId xmlns:a16="http://schemas.microsoft.com/office/drawing/2014/main" id="{D4A6CEA3-8518-418A-B638-84A7B645A540}"/>
+          <p:cNvPr id="13" name="Rectangle 12">
+            <a:extLst>
+              <a:ext uri="{FF2B5EF4-FFF2-40B4-BE49-F238E27FC236}">
+                <a16:creationId xmlns:a16="http://schemas.microsoft.com/office/drawing/2014/main" id="{C5739DAE-FE61-4C98-8DBC-37F6424F9B50}"/>
               </a:ext>
             </a:extLst>
           </p:cNvPr>
@@ -3642,8 +3647,8 @@
         </p:nvSpPr>
         <p:spPr>
           <a:xfrm>
-            <a:off x="1824134" y="5066209"/>
-            <a:ext cx="3965252" cy="545266"/>
+            <a:off x="3546410" y="2895422"/>
+            <a:ext cx="5099179" cy="3176043"/>
           </a:xfrm>
           <a:prstGeom prst="rect">
             <a:avLst/>
@@ -3670,7 +3675,7 @@
             <a:pPr algn="ctr"/>
             <a:r>
               <a:rPr lang="en-GB" dirty="0" err="1"/>
-              <a:t>Question.tsx</a:t>
+              <a:t>HomePage.tsx</a:t>
             </a:r>
             <a:endParaRPr lang="en-GB" dirty="0"/>
           </a:p>
@@ -3678,10 +3683,10 @@
       </p:sp>
       <p:sp>
         <p:nvSpPr>
-          <p:cNvPr id="7" name="Rectangle 6">
-            <a:extLst>
-              <a:ext uri="{FF2B5EF4-FFF2-40B4-BE49-F238E27FC236}">
-                <a16:creationId xmlns:a16="http://schemas.microsoft.com/office/drawing/2014/main" id="{5F54E731-6542-448F-8628-81FFB3CB153C}"/>
+          <p:cNvPr id="5" name="Rectangle 4">
+            <a:extLst>
+              <a:ext uri="{FF2B5EF4-FFF2-40B4-BE49-F238E27FC236}">
+                <a16:creationId xmlns:a16="http://schemas.microsoft.com/office/drawing/2014/main" id="{6939E023-390B-4E1C-94A8-5C94AE9DDE47}"/>
               </a:ext>
             </a:extLst>
           </p:cNvPr>
@@ -3690,8 +3695,104 @@
         </p:nvSpPr>
         <p:spPr>
           <a:xfrm>
-            <a:off x="1824134" y="4049975"/>
-            <a:ext cx="3965252" cy="426098"/>
+            <a:off x="3750842" y="4233686"/>
+            <a:ext cx="4661484" cy="1577721"/>
+          </a:xfrm>
+          <a:prstGeom prst="rect">
+            <a:avLst/>
+          </a:prstGeom>
+        </p:spPr>
+        <p:style>
+          <a:lnRef idx="2">
+            <a:schemeClr val="accent3"/>
+          </a:lnRef>
+          <a:fillRef idx="1">
+            <a:schemeClr val="lt1"/>
+          </a:fillRef>
+          <a:effectRef idx="0">
+            <a:schemeClr val="accent3"/>
+          </a:effectRef>
+          <a:fontRef idx="minor">
+            <a:schemeClr val="dk1"/>
+          </a:fontRef>
+        </p:style>
+        <p:txBody>
+          <a:bodyPr rtlCol="0" anchor="t" anchorCtr="0"/>
+          <a:lstStyle/>
+          <a:p>
+            <a:pPr algn="ctr"/>
+            <a:r>
+              <a:rPr lang="en-GB" dirty="0" err="1"/>
+              <a:t>QuestionList.tsx</a:t>
+            </a:r>
+            <a:endParaRPr lang="en-GB" dirty="0"/>
+          </a:p>
+        </p:txBody>
+      </p:sp>
+      <p:sp>
+        <p:nvSpPr>
+          <p:cNvPr id="6" name="Rectangle 5">
+            <a:extLst>
+              <a:ext uri="{FF2B5EF4-FFF2-40B4-BE49-F238E27FC236}">
+                <a16:creationId xmlns:a16="http://schemas.microsoft.com/office/drawing/2014/main" id="{D4A6CEA3-8518-418A-B638-84A7B645A540}"/>
+              </a:ext>
+            </a:extLst>
+          </p:cNvPr>
+          <p:cNvSpPr/>
+          <p:nvPr/>
+        </p:nvSpPr>
+        <p:spPr>
+          <a:xfrm>
+            <a:off x="4121928" y="5370003"/>
+            <a:ext cx="3965252" cy="338748"/>
+          </a:xfrm>
+          <a:prstGeom prst="rect">
+            <a:avLst/>
+          </a:prstGeom>
+        </p:spPr>
+        <p:style>
+          <a:lnRef idx="2">
+            <a:schemeClr val="accent3"/>
+          </a:lnRef>
+          <a:fillRef idx="1">
+            <a:schemeClr val="lt1"/>
+          </a:fillRef>
+          <a:effectRef idx="0">
+            <a:schemeClr val="accent3"/>
+          </a:effectRef>
+          <a:fontRef idx="minor">
+            <a:schemeClr val="dk1"/>
+          </a:fontRef>
+        </p:style>
+        <p:txBody>
+          <a:bodyPr rtlCol="0" anchor="t" anchorCtr="0"/>
+          <a:lstStyle/>
+          <a:p>
+            <a:pPr algn="ctr"/>
+            <a:r>
+              <a:rPr lang="en-GB" dirty="0" err="1"/>
+              <a:t>Question.tsx</a:t>
+            </a:r>
+            <a:endParaRPr lang="en-GB" dirty="0"/>
+          </a:p>
+        </p:txBody>
+      </p:sp>
+      <p:sp>
+        <p:nvSpPr>
+          <p:cNvPr id="7" name="Rectangle 6">
+            <a:extLst>
+              <a:ext uri="{FF2B5EF4-FFF2-40B4-BE49-F238E27FC236}">
+                <a16:creationId xmlns:a16="http://schemas.microsoft.com/office/drawing/2014/main" id="{5F54E731-6542-448F-8628-81FFB3CB153C}"/>
+              </a:ext>
+            </a:extLst>
+          </p:cNvPr>
+          <p:cNvSpPr/>
+          <p:nvPr/>
+        </p:nvSpPr>
+        <p:spPr>
+          <a:xfrm>
+            <a:off x="4140459" y="4572437"/>
+            <a:ext cx="3965252" cy="347489"/>
           </a:xfrm>
           <a:prstGeom prst="rect">
             <a:avLst/>
@@ -3744,8 +3845,8 @@
         </p:nvSpPr>
         <p:spPr>
           <a:xfrm>
-            <a:off x="1824134" y="4558091"/>
-            <a:ext cx="3965252" cy="426099"/>
+            <a:off x="4129703" y="4988544"/>
+            <a:ext cx="3965252" cy="338749"/>
           </a:xfrm>
           <a:prstGeom prst="rect">
             <a:avLst/>
@@ -3794,8 +3895,8 @@
         </p:nvSpPr>
         <p:spPr>
           <a:xfrm>
-            <a:off x="1254968" y="2496274"/>
-            <a:ext cx="5066522" cy="426098"/>
+            <a:off x="3750840" y="3243495"/>
+            <a:ext cx="4661485" cy="426098"/>
           </a:xfrm>
           <a:prstGeom prst="rect">
             <a:avLst/>
@@ -3844,8 +3945,8 @@
         </p:nvSpPr>
         <p:spPr>
           <a:xfrm>
-            <a:off x="1254968" y="3046438"/>
-            <a:ext cx="5066522" cy="426099"/>
+            <a:off x="3743065" y="3738969"/>
+            <a:ext cx="4661485" cy="426099"/>
           </a:xfrm>
           <a:prstGeom prst="rect">
             <a:avLst/>

</xml_diff>

<commit_message>
Simple Query Parameters and Search Result
</commit_message>
<xml_diff>
--- a/ComponentStructure.pptx
+++ b/ComponentStructure.pptx
@@ -6,6 +6,7 @@
   </p:sldMasterIdLst>
   <p:sldIdLst>
     <p:sldId id="256" r:id="rId2"/>
+    <p:sldId id="257" r:id="rId3"/>
   </p:sldIdLst>
   <p:sldSz cx="12192000" cy="6858000"/>
   <p:notesSz cx="6858000" cy="9144000"/>
@@ -3579,7 +3580,7 @@
             <a:pPr algn="ctr"/>
             <a:r>
               <a:rPr lang="en-GB" dirty="0" err="1"/>
-              <a:t>Page.tsx</a:t>
+              <a:t>HomePage.tsx</a:t>
             </a:r>
             <a:endParaRPr lang="en-GB" dirty="0"/>
           </a:p>
@@ -3675,7 +3676,7 @@
             <a:pPr algn="ctr"/>
             <a:r>
               <a:rPr lang="en-GB" dirty="0" err="1"/>
-              <a:t>HomePage.tsx</a:t>
+              <a:t>Page.tsx</a:t>
             </a:r>
             <a:endParaRPr lang="en-GB" dirty="0"/>
           </a:p>
@@ -3985,6 +3986,674 @@
     <p:extLst>
       <p:ext uri="{BB962C8B-B14F-4D97-AF65-F5344CB8AC3E}">
         <p14:creationId xmlns:p14="http://schemas.microsoft.com/office/powerpoint/2010/main" val="792148593"/>
+      </p:ext>
+    </p:extLst>
+  </p:cSld>
+  <p:clrMapOvr>
+    <a:masterClrMapping/>
+  </p:clrMapOvr>
+</p:sld>
+</file>
+
+<file path=ppt/slides/slide2.xml><?xml version="1.0" encoding="utf-8"?>
+<p:sld xmlns:a="http://schemas.openxmlformats.org/drawingml/2006/main" xmlns:r="http://schemas.openxmlformats.org/officeDocument/2006/relationships" xmlns:p="http://schemas.openxmlformats.org/presentationml/2006/main">
+  <p:cSld>
+    <p:spTree>
+      <p:nvGrpSpPr>
+        <p:cNvPr id="1" name=""/>
+        <p:cNvGrpSpPr/>
+        <p:nvPr/>
+      </p:nvGrpSpPr>
+      <p:grpSpPr>
+        <a:xfrm>
+          <a:off x="0" y="0"/>
+          <a:ext cx="0" cy="0"/>
+          <a:chOff x="0" y="0"/>
+          <a:chExt cx="0" cy="0"/>
+        </a:xfrm>
+      </p:grpSpPr>
+      <p:sp>
+        <p:nvSpPr>
+          <p:cNvPr id="4" name="Rectangle 3">
+            <a:extLst>
+              <a:ext uri="{FF2B5EF4-FFF2-40B4-BE49-F238E27FC236}">
+                <a16:creationId xmlns:a16="http://schemas.microsoft.com/office/drawing/2014/main" id="{6CF8572A-314B-4C23-B4F9-21BF983FB1C6}"/>
+              </a:ext>
+            </a:extLst>
+          </p:cNvPr>
+          <p:cNvSpPr/>
+          <p:nvPr/>
+        </p:nvSpPr>
+        <p:spPr>
+          <a:xfrm>
+            <a:off x="411062" y="335560"/>
+            <a:ext cx="11325136" cy="6258187"/>
+          </a:xfrm>
+          <a:prstGeom prst="rect">
+            <a:avLst/>
+          </a:prstGeom>
+        </p:spPr>
+        <p:style>
+          <a:lnRef idx="2">
+            <a:schemeClr val="accent3"/>
+          </a:lnRef>
+          <a:fillRef idx="1">
+            <a:schemeClr val="lt1"/>
+          </a:fillRef>
+          <a:effectRef idx="0">
+            <a:schemeClr val="accent3"/>
+          </a:effectRef>
+          <a:fontRef idx="minor">
+            <a:schemeClr val="dk1"/>
+          </a:fontRef>
+        </p:style>
+        <p:txBody>
+          <a:bodyPr rtlCol="0" anchor="ctr"/>
+          <a:lstStyle/>
+          <a:p>
+            <a:pPr algn="ctr"/>
+            <a:endParaRPr lang="en-GB"/>
+          </a:p>
+        </p:txBody>
+      </p:sp>
+      <p:sp>
+        <p:nvSpPr>
+          <p:cNvPr id="9" name="Rectangle 8">
+            <a:extLst>
+              <a:ext uri="{FF2B5EF4-FFF2-40B4-BE49-F238E27FC236}">
+                <a16:creationId xmlns:a16="http://schemas.microsoft.com/office/drawing/2014/main" id="{7F06A212-51A1-4430-B27F-2A381287897A}"/>
+              </a:ext>
+            </a:extLst>
+          </p:cNvPr>
+          <p:cNvSpPr/>
+          <p:nvPr/>
+        </p:nvSpPr>
+        <p:spPr>
+          <a:xfrm>
+            <a:off x="534955" y="447870"/>
+            <a:ext cx="11100318" cy="1198094"/>
+          </a:xfrm>
+          <a:prstGeom prst="rect">
+            <a:avLst/>
+          </a:prstGeom>
+        </p:spPr>
+        <p:style>
+          <a:lnRef idx="2">
+            <a:schemeClr val="accent3"/>
+          </a:lnRef>
+          <a:fillRef idx="1">
+            <a:schemeClr val="lt1"/>
+          </a:fillRef>
+          <a:effectRef idx="0">
+            <a:schemeClr val="accent3"/>
+          </a:effectRef>
+          <a:fontRef idx="minor">
+            <a:schemeClr val="dk1"/>
+          </a:fontRef>
+        </p:style>
+        <p:txBody>
+          <a:bodyPr rtlCol="0" anchor="t" anchorCtr="0"/>
+          <a:lstStyle/>
+          <a:p>
+            <a:pPr algn="ctr"/>
+            <a:r>
+              <a:rPr lang="en-GB" dirty="0" err="1"/>
+              <a:t>Header.tsx</a:t>
+            </a:r>
+            <a:endParaRPr lang="en-GB" dirty="0"/>
+          </a:p>
+        </p:txBody>
+      </p:sp>
+      <p:sp>
+        <p:nvSpPr>
+          <p:cNvPr id="11" name="Rectangle 10">
+            <a:extLst>
+              <a:ext uri="{FF2B5EF4-FFF2-40B4-BE49-F238E27FC236}">
+                <a16:creationId xmlns:a16="http://schemas.microsoft.com/office/drawing/2014/main" id="{F10854EF-EA40-4A5F-BA8B-728C129B641C}"/>
+              </a:ext>
+            </a:extLst>
+          </p:cNvPr>
+          <p:cNvSpPr/>
+          <p:nvPr/>
+        </p:nvSpPr>
+        <p:spPr>
+          <a:xfrm>
+            <a:off x="9731828" y="1027651"/>
+            <a:ext cx="1763228" cy="426098"/>
+          </a:xfrm>
+          <a:prstGeom prst="rect">
+            <a:avLst/>
+          </a:prstGeom>
+        </p:spPr>
+        <p:style>
+          <a:lnRef idx="2">
+            <a:schemeClr val="accent3"/>
+          </a:lnRef>
+          <a:fillRef idx="1">
+            <a:schemeClr val="lt1"/>
+          </a:fillRef>
+          <a:effectRef idx="0">
+            <a:schemeClr val="accent3"/>
+          </a:effectRef>
+          <a:fontRef idx="minor">
+            <a:schemeClr val="dk1"/>
+          </a:fontRef>
+        </p:style>
+        <p:txBody>
+          <a:bodyPr rtlCol="0" anchor="t" anchorCtr="0"/>
+          <a:lstStyle/>
+          <a:p>
+            <a:pPr algn="ctr"/>
+            <a:r>
+              <a:rPr lang="en-GB" dirty="0" err="1"/>
+              <a:t>Icon.tsx</a:t>
+            </a:r>
+            <a:endParaRPr lang="en-GB" dirty="0"/>
+          </a:p>
+        </p:txBody>
+      </p:sp>
+      <p:sp>
+        <p:nvSpPr>
+          <p:cNvPr id="12" name="Rectangle 11">
+            <a:extLst>
+              <a:ext uri="{FF2B5EF4-FFF2-40B4-BE49-F238E27FC236}">
+                <a16:creationId xmlns:a16="http://schemas.microsoft.com/office/drawing/2014/main" id="{695DEA8B-6C91-4B95-A735-01F77422942F}"/>
+              </a:ext>
+            </a:extLst>
+          </p:cNvPr>
+          <p:cNvSpPr/>
+          <p:nvPr/>
+        </p:nvSpPr>
+        <p:spPr>
+          <a:xfrm>
+            <a:off x="7392696" y="1027651"/>
+            <a:ext cx="2198915" cy="426099"/>
+          </a:xfrm>
+          <a:prstGeom prst="rect">
+            <a:avLst/>
+          </a:prstGeom>
+        </p:spPr>
+        <p:style>
+          <a:lnRef idx="2">
+            <a:schemeClr val="accent3">
+              <a:shade val="50000"/>
+            </a:schemeClr>
+          </a:lnRef>
+          <a:fillRef idx="1">
+            <a:schemeClr val="accent3"/>
+          </a:fillRef>
+          <a:effectRef idx="0">
+            <a:schemeClr val="accent3"/>
+          </a:effectRef>
+          <a:fontRef idx="minor">
+            <a:schemeClr val="lt1"/>
+          </a:fontRef>
+        </p:style>
+        <p:txBody>
+          <a:bodyPr rtlCol="0" anchor="t" anchorCtr="0"/>
+          <a:lstStyle/>
+          <a:p>
+            <a:pPr algn="ctr"/>
+            <a:r>
+              <a:rPr lang="en-GB" dirty="0" err="1"/>
+              <a:t>Styles.ts</a:t>
+            </a:r>
+            <a:endParaRPr lang="en-GB" dirty="0"/>
+          </a:p>
+        </p:txBody>
+      </p:sp>
+      <p:sp>
+        <p:nvSpPr>
+          <p:cNvPr id="16" name="Rectangle 15">
+            <a:extLst>
+              <a:ext uri="{FF2B5EF4-FFF2-40B4-BE49-F238E27FC236}">
+                <a16:creationId xmlns:a16="http://schemas.microsoft.com/office/drawing/2014/main" id="{CB6B30B4-5F78-4EF5-86A5-C87AB7C0EECD}"/>
+              </a:ext>
+            </a:extLst>
+          </p:cNvPr>
+          <p:cNvSpPr/>
+          <p:nvPr/>
+        </p:nvSpPr>
+        <p:spPr>
+          <a:xfrm>
+            <a:off x="534955" y="1758274"/>
+            <a:ext cx="11100318" cy="4651856"/>
+          </a:xfrm>
+          <a:prstGeom prst="rect">
+            <a:avLst/>
+          </a:prstGeom>
+        </p:spPr>
+        <p:style>
+          <a:lnRef idx="2">
+            <a:schemeClr val="accent3"/>
+          </a:lnRef>
+          <a:fillRef idx="1">
+            <a:schemeClr val="lt1"/>
+          </a:fillRef>
+          <a:effectRef idx="0">
+            <a:schemeClr val="accent3"/>
+          </a:effectRef>
+          <a:fontRef idx="minor">
+            <a:schemeClr val="dk1"/>
+          </a:fontRef>
+        </p:style>
+        <p:txBody>
+          <a:bodyPr rtlCol="0" anchor="t" anchorCtr="0"/>
+          <a:lstStyle/>
+          <a:p>
+            <a:pPr algn="ctr"/>
+            <a:r>
+              <a:rPr lang="en-GB"/>
+              <a:t>QuestionPage.</a:t>
+            </a:r>
+            <a:r>
+              <a:rPr lang="en-GB" dirty="0" err="1"/>
+              <a:t>tsx</a:t>
+            </a:r>
+            <a:endParaRPr lang="en-GB" dirty="0"/>
+          </a:p>
+        </p:txBody>
+      </p:sp>
+      <p:sp>
+        <p:nvSpPr>
+          <p:cNvPr id="17" name="Rectangle 16">
+            <a:extLst>
+              <a:ext uri="{FF2B5EF4-FFF2-40B4-BE49-F238E27FC236}">
+                <a16:creationId xmlns:a16="http://schemas.microsoft.com/office/drawing/2014/main" id="{3EE5B209-AC34-4ED6-AB66-C493580892F1}"/>
+              </a:ext>
+            </a:extLst>
+          </p:cNvPr>
+          <p:cNvSpPr/>
+          <p:nvPr/>
+        </p:nvSpPr>
+        <p:spPr>
+          <a:xfrm>
+            <a:off x="3546410" y="2348916"/>
+            <a:ext cx="5099179" cy="423147"/>
+          </a:xfrm>
+          <a:prstGeom prst="rect">
+            <a:avLst/>
+          </a:prstGeom>
+        </p:spPr>
+        <p:style>
+          <a:lnRef idx="2">
+            <a:schemeClr val="accent3"/>
+          </a:lnRef>
+          <a:fillRef idx="1">
+            <a:schemeClr val="lt1"/>
+          </a:fillRef>
+          <a:effectRef idx="0">
+            <a:schemeClr val="accent3"/>
+          </a:effectRef>
+          <a:fontRef idx="minor">
+            <a:schemeClr val="dk1"/>
+          </a:fontRef>
+        </p:style>
+        <p:txBody>
+          <a:bodyPr rtlCol="0" anchor="t" anchorCtr="0"/>
+          <a:lstStyle/>
+          <a:p>
+            <a:pPr algn="ctr"/>
+            <a:r>
+              <a:rPr lang="en-GB" dirty="0" err="1"/>
+              <a:t>PageTitle.tsx</a:t>
+            </a:r>
+            <a:endParaRPr lang="en-GB" dirty="0"/>
+          </a:p>
+        </p:txBody>
+      </p:sp>
+      <p:sp>
+        <p:nvSpPr>
+          <p:cNvPr id="13" name="Rectangle 12">
+            <a:extLst>
+              <a:ext uri="{FF2B5EF4-FFF2-40B4-BE49-F238E27FC236}">
+                <a16:creationId xmlns:a16="http://schemas.microsoft.com/office/drawing/2014/main" id="{C5739DAE-FE61-4C98-8DBC-37F6424F9B50}"/>
+              </a:ext>
+            </a:extLst>
+          </p:cNvPr>
+          <p:cNvSpPr/>
+          <p:nvPr/>
+        </p:nvSpPr>
+        <p:spPr>
+          <a:xfrm>
+            <a:off x="3546410" y="2895422"/>
+            <a:ext cx="5099179" cy="3176043"/>
+          </a:xfrm>
+          <a:prstGeom prst="rect">
+            <a:avLst/>
+          </a:prstGeom>
+        </p:spPr>
+        <p:style>
+          <a:lnRef idx="2">
+            <a:schemeClr val="accent3"/>
+          </a:lnRef>
+          <a:fillRef idx="1">
+            <a:schemeClr val="lt1"/>
+          </a:fillRef>
+          <a:effectRef idx="0">
+            <a:schemeClr val="accent3"/>
+          </a:effectRef>
+          <a:fontRef idx="minor">
+            <a:schemeClr val="dk1"/>
+          </a:fontRef>
+        </p:style>
+        <p:txBody>
+          <a:bodyPr rtlCol="0" anchor="t" anchorCtr="0"/>
+          <a:lstStyle/>
+          <a:p>
+            <a:pPr algn="ctr"/>
+            <a:r>
+              <a:rPr lang="en-GB" dirty="0" err="1"/>
+              <a:t>Page.tsx</a:t>
+            </a:r>
+            <a:endParaRPr lang="en-GB" dirty="0"/>
+          </a:p>
+        </p:txBody>
+      </p:sp>
+      <p:sp>
+        <p:nvSpPr>
+          <p:cNvPr id="5" name="Rectangle 4">
+            <a:extLst>
+              <a:ext uri="{FF2B5EF4-FFF2-40B4-BE49-F238E27FC236}">
+                <a16:creationId xmlns:a16="http://schemas.microsoft.com/office/drawing/2014/main" id="{6939E023-390B-4E1C-94A8-5C94AE9DDE47}"/>
+              </a:ext>
+            </a:extLst>
+          </p:cNvPr>
+          <p:cNvSpPr/>
+          <p:nvPr/>
+        </p:nvSpPr>
+        <p:spPr>
+          <a:xfrm>
+            <a:off x="3750842" y="4233686"/>
+            <a:ext cx="4661484" cy="1577721"/>
+          </a:xfrm>
+          <a:prstGeom prst="rect">
+            <a:avLst/>
+          </a:prstGeom>
+        </p:spPr>
+        <p:style>
+          <a:lnRef idx="2">
+            <a:schemeClr val="accent3"/>
+          </a:lnRef>
+          <a:fillRef idx="1">
+            <a:schemeClr val="lt1"/>
+          </a:fillRef>
+          <a:effectRef idx="0">
+            <a:schemeClr val="accent3"/>
+          </a:effectRef>
+          <a:fontRef idx="minor">
+            <a:schemeClr val="dk1"/>
+          </a:fontRef>
+        </p:style>
+        <p:txBody>
+          <a:bodyPr rtlCol="0" anchor="t" anchorCtr="0"/>
+          <a:lstStyle/>
+          <a:p>
+            <a:pPr algn="ctr"/>
+            <a:r>
+              <a:rPr lang="en-GB" dirty="0" err="1"/>
+              <a:t>QuestionList.tsx</a:t>
+            </a:r>
+            <a:endParaRPr lang="en-GB" dirty="0"/>
+          </a:p>
+        </p:txBody>
+      </p:sp>
+      <p:sp>
+        <p:nvSpPr>
+          <p:cNvPr id="6" name="Rectangle 5">
+            <a:extLst>
+              <a:ext uri="{FF2B5EF4-FFF2-40B4-BE49-F238E27FC236}">
+                <a16:creationId xmlns:a16="http://schemas.microsoft.com/office/drawing/2014/main" id="{D4A6CEA3-8518-418A-B638-84A7B645A540}"/>
+              </a:ext>
+            </a:extLst>
+          </p:cNvPr>
+          <p:cNvSpPr/>
+          <p:nvPr/>
+        </p:nvSpPr>
+        <p:spPr>
+          <a:xfrm>
+            <a:off x="4121928" y="5370003"/>
+            <a:ext cx="3965252" cy="338748"/>
+          </a:xfrm>
+          <a:prstGeom prst="rect">
+            <a:avLst/>
+          </a:prstGeom>
+        </p:spPr>
+        <p:style>
+          <a:lnRef idx="2">
+            <a:schemeClr val="accent3"/>
+          </a:lnRef>
+          <a:fillRef idx="1">
+            <a:schemeClr val="lt1"/>
+          </a:fillRef>
+          <a:effectRef idx="0">
+            <a:schemeClr val="accent3"/>
+          </a:effectRef>
+          <a:fontRef idx="minor">
+            <a:schemeClr val="dk1"/>
+          </a:fontRef>
+        </p:style>
+        <p:txBody>
+          <a:bodyPr rtlCol="0" anchor="t" anchorCtr="0"/>
+          <a:lstStyle/>
+          <a:p>
+            <a:pPr algn="ctr"/>
+            <a:r>
+              <a:rPr lang="en-GB" dirty="0" err="1"/>
+              <a:t>Question.tsx</a:t>
+            </a:r>
+            <a:endParaRPr lang="en-GB" dirty="0"/>
+          </a:p>
+        </p:txBody>
+      </p:sp>
+      <p:sp>
+        <p:nvSpPr>
+          <p:cNvPr id="7" name="Rectangle 6">
+            <a:extLst>
+              <a:ext uri="{FF2B5EF4-FFF2-40B4-BE49-F238E27FC236}">
+                <a16:creationId xmlns:a16="http://schemas.microsoft.com/office/drawing/2014/main" id="{5F54E731-6542-448F-8628-81FFB3CB153C}"/>
+              </a:ext>
+            </a:extLst>
+          </p:cNvPr>
+          <p:cNvSpPr/>
+          <p:nvPr/>
+        </p:nvSpPr>
+        <p:spPr>
+          <a:xfrm>
+            <a:off x="4140459" y="4572437"/>
+            <a:ext cx="3965252" cy="347489"/>
+          </a:xfrm>
+          <a:prstGeom prst="rect">
+            <a:avLst/>
+          </a:prstGeom>
+        </p:spPr>
+        <p:style>
+          <a:lnRef idx="2">
+            <a:schemeClr val="accent3">
+              <a:shade val="50000"/>
+            </a:schemeClr>
+          </a:lnRef>
+          <a:fillRef idx="1">
+            <a:schemeClr val="accent3"/>
+          </a:fillRef>
+          <a:effectRef idx="0">
+            <a:schemeClr val="accent3"/>
+          </a:effectRef>
+          <a:fontRef idx="minor">
+            <a:schemeClr val="lt1"/>
+          </a:fontRef>
+        </p:style>
+        <p:txBody>
+          <a:bodyPr rtlCol="0" anchor="t" anchorCtr="0"/>
+          <a:lstStyle/>
+          <a:p>
+            <a:pPr algn="ctr"/>
+            <a:r>
+              <a:rPr lang="en-GB" dirty="0"/>
+              <a:t>Prop: </a:t>
+            </a:r>
+            <a:r>
+              <a:rPr lang="en-GB" dirty="0" err="1"/>
+              <a:t>QuestionData.ts</a:t>
+            </a:r>
+            <a:endParaRPr lang="en-GB" dirty="0"/>
+          </a:p>
+        </p:txBody>
+      </p:sp>
+      <p:sp>
+        <p:nvSpPr>
+          <p:cNvPr id="8" name="Rectangle 7">
+            <a:extLst>
+              <a:ext uri="{FF2B5EF4-FFF2-40B4-BE49-F238E27FC236}">
+                <a16:creationId xmlns:a16="http://schemas.microsoft.com/office/drawing/2014/main" id="{E0BA672D-8FD7-4704-8130-41F983334156}"/>
+              </a:ext>
+            </a:extLst>
+          </p:cNvPr>
+          <p:cNvSpPr/>
+          <p:nvPr/>
+        </p:nvSpPr>
+        <p:spPr>
+          <a:xfrm>
+            <a:off x="4129703" y="4988544"/>
+            <a:ext cx="3965252" cy="338749"/>
+          </a:xfrm>
+          <a:prstGeom prst="rect">
+            <a:avLst/>
+          </a:prstGeom>
+        </p:spPr>
+        <p:style>
+          <a:lnRef idx="2">
+            <a:schemeClr val="accent3">
+              <a:shade val="50000"/>
+            </a:schemeClr>
+          </a:lnRef>
+          <a:fillRef idx="1">
+            <a:schemeClr val="accent3"/>
+          </a:fillRef>
+          <a:effectRef idx="0">
+            <a:schemeClr val="accent3"/>
+          </a:effectRef>
+          <a:fontRef idx="minor">
+            <a:schemeClr val="lt1"/>
+          </a:fontRef>
+        </p:style>
+        <p:txBody>
+          <a:bodyPr rtlCol="0" anchor="t" anchorCtr="0"/>
+          <a:lstStyle/>
+          <a:p>
+            <a:pPr algn="ctr"/>
+            <a:r>
+              <a:rPr lang="en-GB" dirty="0" err="1"/>
+              <a:t>Styles.ts</a:t>
+            </a:r>
+            <a:endParaRPr lang="en-GB" dirty="0"/>
+          </a:p>
+        </p:txBody>
+      </p:sp>
+      <p:sp>
+        <p:nvSpPr>
+          <p:cNvPr id="14" name="Rectangle 13">
+            <a:extLst>
+              <a:ext uri="{FF2B5EF4-FFF2-40B4-BE49-F238E27FC236}">
+                <a16:creationId xmlns:a16="http://schemas.microsoft.com/office/drawing/2014/main" id="{9F1341EB-2BBC-46D6-A6C1-1C816A517694}"/>
+              </a:ext>
+            </a:extLst>
+          </p:cNvPr>
+          <p:cNvSpPr/>
+          <p:nvPr/>
+        </p:nvSpPr>
+        <p:spPr>
+          <a:xfrm>
+            <a:off x="3750840" y="3243495"/>
+            <a:ext cx="4661485" cy="426098"/>
+          </a:xfrm>
+          <a:prstGeom prst="rect">
+            <a:avLst/>
+          </a:prstGeom>
+        </p:spPr>
+        <p:style>
+          <a:lnRef idx="2">
+            <a:schemeClr val="accent3">
+              <a:shade val="50000"/>
+            </a:schemeClr>
+          </a:lnRef>
+          <a:fillRef idx="1">
+            <a:schemeClr val="accent3"/>
+          </a:fillRef>
+          <a:effectRef idx="0">
+            <a:schemeClr val="accent3"/>
+          </a:effectRef>
+          <a:fontRef idx="minor">
+            <a:schemeClr val="lt1"/>
+          </a:fontRef>
+        </p:style>
+        <p:txBody>
+          <a:bodyPr rtlCol="0" anchor="t" anchorCtr="0"/>
+          <a:lstStyle/>
+          <a:p>
+            <a:pPr algn="ctr"/>
+            <a:r>
+              <a:rPr lang="en-GB" dirty="0" err="1"/>
+              <a:t>QuestionData.ts</a:t>
+            </a:r>
+            <a:endParaRPr lang="en-GB" dirty="0"/>
+          </a:p>
+        </p:txBody>
+      </p:sp>
+      <p:sp>
+        <p:nvSpPr>
+          <p:cNvPr id="15" name="Rectangle 14">
+            <a:extLst>
+              <a:ext uri="{FF2B5EF4-FFF2-40B4-BE49-F238E27FC236}">
+                <a16:creationId xmlns:a16="http://schemas.microsoft.com/office/drawing/2014/main" id="{27BAB6DC-09A1-4E38-A073-215D5F303164}"/>
+              </a:ext>
+            </a:extLst>
+          </p:cNvPr>
+          <p:cNvSpPr/>
+          <p:nvPr/>
+        </p:nvSpPr>
+        <p:spPr>
+          <a:xfrm>
+            <a:off x="3743065" y="3738969"/>
+            <a:ext cx="4661485" cy="426099"/>
+          </a:xfrm>
+          <a:prstGeom prst="rect">
+            <a:avLst/>
+          </a:prstGeom>
+        </p:spPr>
+        <p:style>
+          <a:lnRef idx="2">
+            <a:schemeClr val="accent3">
+              <a:shade val="50000"/>
+            </a:schemeClr>
+          </a:lnRef>
+          <a:fillRef idx="1">
+            <a:schemeClr val="accent3"/>
+          </a:fillRef>
+          <a:effectRef idx="0">
+            <a:schemeClr val="accent3"/>
+          </a:effectRef>
+          <a:fontRef idx="minor">
+            <a:schemeClr val="lt1"/>
+          </a:fontRef>
+        </p:style>
+        <p:txBody>
+          <a:bodyPr rtlCol="0" anchor="t" anchorCtr="0"/>
+          <a:lstStyle/>
+          <a:p>
+            <a:pPr algn="ctr"/>
+            <a:r>
+              <a:rPr lang="en-GB" dirty="0" err="1"/>
+              <a:t>Styles.ts</a:t>
+            </a:r>
+            <a:endParaRPr lang="en-GB" dirty="0"/>
+          </a:p>
+        </p:txBody>
+      </p:sp>
+    </p:spTree>
+    <p:extLst>
+      <p:ext uri="{BB962C8B-B14F-4D97-AF65-F5344CB8AC3E}">
+        <p14:creationId xmlns:p14="http://schemas.microsoft.com/office/powerpoint/2010/main" val="1689185354"/>
       </p:ext>
     </p:extLst>
   </p:cSld>

</xml_diff>